<commit_message>
results: annealed budget sweep — transfer degrades with budget and never beats the untrained encoder
Twelve runs (3 objectives x 2 seeds x 2 budgets) with the learning-rate schedule
annealed to zero in every run. No condition beats a random-initialised encoder at
either budget, and a 7x larger budget costs 0.04-0.05 accuracy while training loss
improves. The earlier non-annealed pass is kept and explicitly marked superseded.
Interim deck updated with the budget chart and corrected result wording.
</commit_message>
<xml_diff>
--- a/docs/Interim_Project_Presentation_7th-sem.pptx
+++ b/docs/Interim_Project_Presentation_7th-sem.pptx
@@ -20060,8 +20060,8 @@
               </a:spcAft>
             </a:pPr>
             <a:r>
-              <a:rPr lang="en-US" dirty="0" sz="1550"/>
-              <a:t>This week: finish the 5M-token sweep (0.7M → 5M, C/A/B, two seeds) and report whether transfer overtakes the random-initialised reference.</a:t>
+              <a:rPr lang="en-US" dirty="0" sz="1450"/>
+              <a:t>Done: 12-run budget sweep (0.69M vs 5M tokens, C/A/B, two seeds, annealed schedules). Result: transfer degrades with budget and never beats the untrained encoder.</a:t>
             </a:r>
             <a:endParaRPr lang="en-IN" dirty="0"/>
           </a:p>
@@ -20075,8 +20075,8 @@
               </a:spcAft>
             </a:pPr>
             <a:r>
-              <a:rPr lang="en-US" dirty="0" sz="1550"/>
-              <a:t>Next: rerun ablations D–G at full budget with probes and a second seed — currently loss-only, single-seed.</a:t>
+              <a:rPr lang="en-US" dirty="0" sz="1450"/>
+              <a:t>Next experiment: probe the same checkpoints on masked versus clean input. If the gap closes, the cause is objective-induced specialisation; if not, the objective is simply weaker here.</a:t>
             </a:r>
             <a:endParaRPr lang="en-IN" dirty="0"/>
           </a:p>
@@ -20090,8 +20090,8 @@
               </a:spcAft>
             </a:pPr>
             <a:r>
-              <a:rPr lang="en-US" dirty="0" sz="1550"/>
-              <a:t>Then: SIGReg-style collapse regulariser (recipe H) and a second probe task (SST-2), so one easy task cannot carry the conclusion.</a:t>
+              <a:rPr lang="en-US" dirty="0" sz="1450"/>
+              <a:t>Then: ablations D–G at full budget with probes and a second seed, plus SIGReg (recipe H) and a second probe task (SST-2), so one easy task cannot carry the conclusion.</a:t>
             </a:r>
             <a:endParaRPr lang="en-IN" dirty="0"/>
           </a:p>
@@ -20105,8 +20105,8 @@
               </a:spcAft>
             </a:pPr>
             <a:r>
-              <a:rPr lang="en-US" dirty="0" sz="1550"/>
-              <a:t>Risks: free-tier quota and session resets (mitigated by committed kernels and hashed artifacts); and the chance that no condition beats the random baseline — reported as the finding if so.</a:t>
+              <a:rPr lang="en-US" dirty="0" sz="1450"/>
+              <a:t>Risks: free-tier quota and session resets (mitigated by committed kernels and hashed artifacts); and the honest chance that no configuration beats an untrained encoder at this scale, which is a reportable finding.</a:t>
             </a:r>
             <a:endParaRPr lang="en-IN" dirty="0"/>
           </a:p>
@@ -20120,7 +20120,7 @@
               </a:spcAft>
             </a:pPr>
             <a:r>
-              <a:rPr lang="en-US" dirty="0" sz="1550"/>
+              <a:rPr lang="en-US" dirty="0" sz="1450"/>
               <a:t>Before final evaluation: full report, final deck, viva preparation.</a:t>
             </a:r>
             <a:endParaRPr lang="en-IN" dirty="0"/>
@@ -20375,12 +20375,12 @@
               </a:spcAft>
             </a:pPr>
             <a:r>
-              <a:rPr lang="en-US" sz="1700" dirty="0">
+              <a:rPr lang="en-US" sz="1650" dirty="0">
                 <a:solidFill>
                   <a:schemeClr val="tx1"/>
                 </a:solidFill>
               </a:rPr>
-              <a:t>A complete, tested system exists: one shared encoder, three matched conditions, one evaluation harness, 55 passing tests.</a:t>
+              <a:t>A complete, tested system exists: one shared encoder, three matched conditions, one evaluation harness, 55 passing tests, twelve GPU runs.</a:t>
             </a:r>
             <a:endParaRPr lang="en-US" sz="2000" b="1" dirty="0">
               <a:solidFill>
@@ -20398,12 +20398,12 @@
               </a:spcAft>
             </a:pPr>
             <a:r>
-              <a:rPr lang="en-US" sz="1700" dirty="0">
+              <a:rPr lang="en-US" sz="1650" dirty="0">
                 <a:solidFill>
                   <a:schemeClr val="tx1"/>
                 </a:solidFill>
               </a:rPr>
-              <a:t>Preliminary (0.7M-token) evidence: optimisation is stable, nothing collapses, and transfer does not yet beat an untrained encoder — a budget effect, reported as such.</a:t>
+              <a:t>Measured result at both budgets: optimisation is stable and nothing collapses, but no condition beats an untrained encoder, and a 7x larger budget makes transfer worse.</a:t>
             </a:r>
             <a:endParaRPr lang="en-US" sz="2000" b="1" dirty="0">
               <a:solidFill>
@@ -20421,12 +20421,12 @@
               </a:spcAft>
             </a:pPr>
             <a:r>
-              <a:rPr lang="en-US" sz="1700" dirty="0">
+              <a:rPr lang="en-US" sz="1650" dirty="0">
                 <a:solidFill>
                   <a:schemeClr val="tx1"/>
                 </a:solidFill>
               </a:rPr>
-              <a:t>The 5M-token sweep decides whether masked-latent targets help at the scale the proposal promised. Either outcome is informative.</a:t>
+              <a:t>That is a negative result with a testable explanation, not a failed experiment. The next run isolates masked-versus-clean input as the cause.</a:t>
             </a:r>
             <a:endParaRPr lang="en-US" sz="2000" b="1" dirty="0">
               <a:solidFill>
@@ -22406,7 +22406,7 @@
         </p:nvSpPr>
         <p:spPr>
           <a:xfrm>
-            <a:off x="495300" y="914400"/>
+            <a:off x="495300" y="932688"/>
             <a:ext cx="4892040" cy="5029200"/>
           </a:xfrm>
           <a:prstGeom prst="rect">
@@ -22433,8 +22433,8 @@
               <a:buNone/>
             </a:pPr>
             <a:r>
-              <a:rPr sz="1450"/>
-              <a:t>55 tests pass (2 skipped: CUDA-only resume, integration-only); ruff clean; resume reproduces state exactly.</a:t>
+              <a:rPr sz="1350"/>
+              <a:t>55 tests pass (2 skipped: CUDA-only resume, integration-only); ruff clean; checkpoints resume with exact state parity.</a:t>
             </a:r>
             <a:endParaRPr lang="en-US" sz="2400" dirty="0">
               <a:solidFill>
@@ -22453,8 +22453,8 @@
               <a:buNone/>
             </a:pPr>
             <a:r>
-              <a:rPr sz="1450"/>
-              <a:t>Training is stable: seed-to-seed spread under 3% (A 0.505 vs 0.519; B 0.150 vs 0.154).</a:t>
+              <a:rPr sz="1350"/>
+              <a:t>Twelve runs completed on a free T4: 3 objectives x 2 seeds x 2 budgets, learning rate annealed to zero in every run.</a:t>
             </a:r>
             <a:endParaRPr lang="en-US" sz="2400" dirty="0">
               <a:solidFill>
@@ -22473,8 +22473,8 @@
               <a:buNone/>
             </a:pPr>
             <a:r>
-              <a:rPr sz="1450"/>
-              <a:t>No collapse: effective rank 76.4 / 80.8 for latent A versus 10.2 / 17.0 for MLM.</a:t>
+              <a:rPr sz="1350"/>
+              <a:t>Losses improve with budget (MLM 7.22 at 0.69M, 7.25 at 5M; latent B 0.146 to 0.088), so the models are learning the training task.</a:t>
             </a:r>
             <a:endParaRPr lang="en-US" sz="2400" dirty="0">
               <a:solidFill>
@@ -22493,8 +22493,8 @@
               <a:buNone/>
             </a:pPr>
             <a:r>
-              <a:rPr sz="1450"/>
-              <a:t>Transfer did not improve: every trained student is below a random-initialised encoder (0.575–0.593 vs 0.632).</a:t>
+              <a:rPr sz="1350"/>
+              <a:t>Transfer gets worse, not better: every condition loses 0.04 to 0.05 accuracy when the budget grows 7x, and all twelve runs stay below an untrained encoder (0.632).</a:t>
             </a:r>
             <a:endParaRPr lang="en-US" sz="2400" dirty="0">
               <a:solidFill>
@@ -22513,8 +22513,8 @@
               <a:buNone/>
             </a:pPr>
             <a:r>
-              <a:rPr sz="1450"/>
-              <a:t>At 0.7M tokens the constraint is budget, not recipe — which the running 5M-token sweep tests.</a:t>
+              <a:rPr sz="1350"/>
+              <a:t>Reading: more training specialises the encoder to masked input; the probe uses clean input. That hypothesis is the next experiment.</a:t>
             </a:r>
             <a:endParaRPr lang="en-US" sz="2400" dirty="0">
               <a:solidFill>
@@ -22526,7 +22526,7 @@
       </p:sp>
       <p:pic>
         <p:nvPicPr>
-          <p:cNvPr id="133" name="Picture 132" descr="fig_probe.png"/>
+          <p:cNvPr id="133" name="Picture 132" descr="fig_budget.png"/>
           <p:cNvPicPr>
             <a:picLocks noChangeAspect="1"/>
           </p:cNvPicPr>
@@ -22540,8 +22540,8 @@
         </p:blipFill>
         <p:spPr>
           <a:xfrm>
-            <a:off x="5532120" y="1417320"/>
-            <a:ext cx="4160520" cy="2569027"/>
+            <a:off x="5440680" y="1600200"/>
+            <a:ext cx="4297680" cy="2540053"/>
           </a:xfrm>
           <a:prstGeom prst="rect">
             <a:avLst/>

</xml_diff>